<commit_message>
Update workshop schedule to Thursday, August 13
The next run of Build Your Own Donna moves to Thursday, August 13 from
2:30 to 4:00 PM ET at Signature's Board Offsite, and the session is 90
minutes rather than two hours.

Pulled through every surface that stated the old schedule:

- index.html: page title, meta description, tagline, hero promise
  ("By 4 PM Thursday"), and the logistics block (date, time, venue)
- README.md: summary line and the attendee-email checklist item, which
  referenced a street address that no longer applies
- assets/build-your-own-donna.pptx: speaker notes on slides 1, 2, and 4
  ("by 4 PM", "the next 90 minutes"). The slide bodies already read
  "90 min", and no slide states a date, so no visible slide text changed.

Time ranges are written with "to" instead of an en dash to match the
house writing style.

Co-Authored-By: Claude Opus 5 <noreply@anthropic.com>
Claude-Session: https://claude.ai/code/session_0182od5NaC1iKXsGsQHjyjnq
</commit_message>
<xml_diff>
--- a/assets/build-your-own-donna.pptx
+++ b/assets/build-your-own-donna.pptx
@@ -810,7 +810,7 @@
                 <a:cs typeface="Arial"/>
                 <a:sym typeface="Arial"/>
               </a:rPr>
-              <a:t>COLD OPEN — let the room settle on the quote before you speak. Opening line: “She ran the best closer in New York City. Today she comes to work for you.” Housekeeping in one breath: laptops out, Claude desktop installed, workspace invite accepted — anyone missing a piece, flag me now, we fix it while we talk. Set the promise: by 3 PM every one of you owns a working Donna — not a demo, yours, on your own inbox.</a:t>
+              <a:t>COLD OPEN — let the room settle on the quote before you speak. Opening line: “She ran the best closer in New York City. Today she comes to work for you.” Housekeeping in one breath: laptops out, Claude desktop installed, workspace invite accepted — anyone missing a piece, flag me now, we fix it while we talk. Set the promise: by 4 PM every one of you owns a working Donna — not a demo, yours, on your own inbox.</a:t>
             </a:r>
             <a:endParaRPr/>
           </a:p>
@@ -2218,7 +2218,7 @@
                 <a:cs typeface="Arial"/>
                 <a:sym typeface="Arial"/>
               </a:rPr>
-              <a:t>COLD OPEN — let the room settle on the quote before you speak. Opening line: “She ran the best closer in New York City. Today she comes to work for you.” Housekeeping in one breath: laptops out, Claude desktop installed, workspace invite accepted — anyone missing a piece, flag me now, we fix it while we talk. Set the promise: by 3 PM every one of you owns a working Donna — not a demo, yours, on your own inbox.</a:t>
+              <a:t>COLD OPEN — let the room settle on the quote before you speak. Opening line: “She ran the best closer in New York City. Today she comes to work for you.” Housekeeping in one breath: laptops out, Claude desktop installed, workspace invite accepted — anyone missing a piece, flag me now, we fix it while we talk. Set the promise: by 4 PM every one of you owns a working Donna — not a demo, yours, on your own inbox.</a:t>
             </a:r>
             <a:endParaRPr/>
           </a:p>
@@ -2578,7 +2578,7 @@
                 <a:cs typeface="Arial"/>
                 <a:sym typeface="Arial"/>
               </a:rPr>
-              <a:t>The want-ad quote is the thesis: the job you’re hiring for isn’t phones and dry cleaning — filters and rules and a tidier inbox are the want-ad version. You’re hiring judgment: something that knows who matters, drafts in your voice, and briefs you once a day. Land the fiction-to-real line and pause — that’s the hook for the next two hours.</a:t>
+              <a:t>The want-ad quote is the thesis: the job you’re hiring for isn’t phones and dry cleaning — filters and rules and a tidier inbox are the want-ad version. You’re hiring judgment: something that knows who matters, drafts in your voice, and briefs you once a day. Land the fiction-to-real line and pause — that’s the hook for the next 90 minutes.</a:t>
             </a:r>
             <a:endParaRPr/>
           </a:p>

</xml_diff>